<commit_message>
Best-vs-paper deck: fix four text errors in make_best_vs_paper_slides.py and rebuild the pptx (deck stage only, no re-simulation)
- Slide 18: missing f-string prefix; the line now prints "Full-data lambda*: 90 refits, 29,520 calls, once."
- Slide 1: device counts derived from the device list: 18 measured devices (8 nMOS, 10 pMOS), was "9 nMOS, 9 pMOS".
- Slide 2: L x W table uses zip_longest and lists all 18 devices; pmos_L8_W1p6 and pmos_L8_W5 were dropped by zip.
- Other hard-coded device counts (18 devices / folds, 17 training devices) derived from the device list; printed values unchanged.

Co-Authored-By: Claude Opus 5.5 <noreply@anthropic.com>
Claude-Session: https://claude.ai/code/session_01FTjyogfhfbXwhjQosGAjKp
</commit_message>
<xml_diff>
--- a/slides/cryo_ml_best_vs_paper.pptx
+++ b/slides/cryo_ml_best_vs_paper.pptx
@@ -3205,7 +3205,7 @@
                   <a:srgbClr val="202428"/>
                 </a:solidFill>
               </a:rPr>
-              <a:t>18 measured devices (9 nMOS, 9 pMOS); ngspice-41; BSIM4 state C; all rows DEV, method draft not frozen; 2026-10-27</a:t>
+              <a:t>18 measured devices (8 nMOS, 10 pMOS); ngspice-41; BSIM4 state C; all rows DEV, method draft not frozen; 2026-10-27</a:t>
             </a:r>
           </a:p>
         </p:txBody>
@@ -11738,7 +11738,7 @@
                   <a:srgbClr val="202428"/>
                 </a:solidFill>
               </a:rPr>
-              <a:t>Selection calls: 1,530 inner refits over 18 folds, estimated as inner refits x median held-out calls (cost.json); 98.9% of the g v2 total. Full-data lambda*: {sel_c['full_data_selection_refits']} refits, 29,520 calls, once.</a:t>
+              <a:t>Selection calls: 1,530 inner refits over 18 folds, estimated as inner refits x median held-out calls (cost.json); 98.9% of the g v2 total. Full-data lambda*: 90 refits, 29,520 calls, once.</a:t>
             </a:r>
           </a:p>
           <a:p>
@@ -13205,7 +13205,7 @@
         </p:nvGraphicFramePr>
         <p:xfrm>
           <a:off x="411480" y="960120"/>
-          <a:ext cx="5029200" cy="2715768"/>
+          <a:ext cx="5029200" cy="3319272"/>
         </p:xfrm>
         <a:graphic>
           <a:graphicData uri="http://schemas.openxmlformats.org/drawingml/2006/table">
@@ -14032,6 +14032,182 @@
                       </a:pPr>
                       <a:r>
                         <a:t>8 x 0.84</a:t>
+                      </a:r>
+                    </a:p>
+                  </a:txBody>
+                  <a:tcPr marL="45720" marR="45720" marT="9144" marB="9144">
+                    <a:solidFill>
+                      <a:srgbClr val="FFFFFF"/>
+                    </a:solidFill>
+                  </a:tcPr>
+                </a:tc>
+                <a:tc>
+                  <a:txBody>
+                    <a:bodyPr/>
+                    <a:lstStyle/>
+                    <a:p>
+                      <a:pPr algn="l">
+                        <a:defRPr sz="1200">
+                          <a:solidFill>
+                            <a:srgbClr val="202428"/>
+                          </a:solidFill>
+                        </a:defRPr>
+                      </a:pPr>
+                      <a:r>
+                        <a:t>9</a:t>
+                      </a:r>
+                    </a:p>
+                  </a:txBody>
+                  <a:tcPr marL="45720" marR="45720" marT="9144" marB="9144">
+                    <a:solidFill>
+                      <a:srgbClr val="FFFFFF"/>
+                    </a:solidFill>
+                  </a:tcPr>
+                </a:tc>
+              </a:tr>
+              <a:tr h="301752">
+                <a:tc>
+                  <a:txBody>
+                    <a:bodyPr/>
+                    <a:lstStyle/>
+                    <a:p>
+                      <a:pPr algn="l">
+                        <a:defRPr sz="1200">
+                          <a:solidFill>
+                            <a:srgbClr val="202428"/>
+                          </a:solidFill>
+                        </a:defRPr>
+                      </a:pPr>
+                    </a:p>
+                  </a:txBody>
+                  <a:tcPr marL="45720" marR="45720" marT="9144" marB="9144">
+                    <a:solidFill>
+                      <a:srgbClr val="FFFFFF"/>
+                    </a:solidFill>
+                  </a:tcPr>
+                </a:tc>
+                <a:tc>
+                  <a:txBody>
+                    <a:bodyPr/>
+                    <a:lstStyle/>
+                    <a:p>
+                      <a:pPr algn="l">
+                        <a:defRPr sz="1200">
+                          <a:solidFill>
+                            <a:srgbClr val="202428"/>
+                          </a:solidFill>
+                        </a:defRPr>
+                      </a:pPr>
+                    </a:p>
+                  </a:txBody>
+                  <a:tcPr marL="45720" marR="45720" marT="9144" marB="9144">
+                    <a:solidFill>
+                      <a:srgbClr val="FFFFFF"/>
+                    </a:solidFill>
+                  </a:tcPr>
+                </a:tc>
+                <a:tc>
+                  <a:txBody>
+                    <a:bodyPr/>
+                    <a:lstStyle/>
+                    <a:p>
+                      <a:pPr algn="l">
+                        <a:defRPr sz="1200">
+                          <a:solidFill>
+                            <a:srgbClr val="202428"/>
+                          </a:solidFill>
+                        </a:defRPr>
+                      </a:pPr>
+                      <a:r>
+                        <a:t>8 x 1.6</a:t>
+                      </a:r>
+                    </a:p>
+                  </a:txBody>
+                  <a:tcPr marL="45720" marR="45720" marT="9144" marB="9144">
+                    <a:solidFill>
+                      <a:srgbClr val="FFFFFF"/>
+                    </a:solidFill>
+                  </a:tcPr>
+                </a:tc>
+                <a:tc>
+                  <a:txBody>
+                    <a:bodyPr/>
+                    <a:lstStyle/>
+                    <a:p>
+                      <a:pPr algn="l">
+                        <a:defRPr sz="1200">
+                          <a:solidFill>
+                            <a:srgbClr val="202428"/>
+                          </a:solidFill>
+                        </a:defRPr>
+                      </a:pPr>
+                      <a:r>
+                        <a:t>9</a:t>
+                      </a:r>
+                    </a:p>
+                  </a:txBody>
+                  <a:tcPr marL="45720" marR="45720" marT="9144" marB="9144">
+                    <a:solidFill>
+                      <a:srgbClr val="FFFFFF"/>
+                    </a:solidFill>
+                  </a:tcPr>
+                </a:tc>
+              </a:tr>
+              <a:tr h="301752">
+                <a:tc>
+                  <a:txBody>
+                    <a:bodyPr/>
+                    <a:lstStyle/>
+                    <a:p>
+                      <a:pPr algn="l">
+                        <a:defRPr sz="1200">
+                          <a:solidFill>
+                            <a:srgbClr val="202428"/>
+                          </a:solidFill>
+                        </a:defRPr>
+                      </a:pPr>
+                    </a:p>
+                  </a:txBody>
+                  <a:tcPr marL="45720" marR="45720" marT="9144" marB="9144">
+                    <a:solidFill>
+                      <a:srgbClr val="FFFFFF"/>
+                    </a:solidFill>
+                  </a:tcPr>
+                </a:tc>
+                <a:tc>
+                  <a:txBody>
+                    <a:bodyPr/>
+                    <a:lstStyle/>
+                    <a:p>
+                      <a:pPr algn="l">
+                        <a:defRPr sz="1200">
+                          <a:solidFill>
+                            <a:srgbClr val="202428"/>
+                          </a:solidFill>
+                        </a:defRPr>
+                      </a:pPr>
+                    </a:p>
+                  </a:txBody>
+                  <a:tcPr marL="45720" marR="45720" marT="9144" marB="9144">
+                    <a:solidFill>
+                      <a:srgbClr val="FFFFFF"/>
+                    </a:solidFill>
+                  </a:tcPr>
+                </a:tc>
+                <a:tc>
+                  <a:txBody>
+                    <a:bodyPr/>
+                    <a:lstStyle/>
+                    <a:p>
+                      <a:pPr algn="l">
+                        <a:defRPr sz="1200">
+                          <a:solidFill>
+                            <a:srgbClr val="202428"/>
+                          </a:solidFill>
+                        </a:defRPr>
+                      </a:pPr>
+                      <a:r>
+                        <a:t>8 x 5</a:t>
                       </a:r>
                     </a:p>
                   </a:txBody>

</xml_diff>